<commit_message>
Business case: drop the references to the existing costing system
The word CAPPe never appeared, but two lines pointed at the same
subject — "it feeds the existing costing system by export" and "does
not replace the established costing method". Both are gone.

The limits line still does its job without going near it: it does not
replace the cost engineer's judgement; it does the data work and the
first pass, and the decisions stay with the engineer.

Verified: validate.py passes, every text block inside its box, and no
reference to a costing system, costing method or estimating system
remains anywhere on the slide.

Co-Authored-By: Claude Opus 5 <noreply@anthropic.com>
Claude-Session: https://claude.ai/code/session_019qdUjZ8WZYLU54FEixJk1i
</commit_message>
<xml_diff>
--- a/BrainSpark_Business_Case.pptx
+++ b/BrainSpark_Business_Case.pptx
@@ -3075,7 +3075,7 @@
                 <a:ea typeface="Arial" pitchFamily="34" charset="-122"/>
                 <a:cs typeface="Arial" pitchFamily="34" charset="-120"/>
               </a:rPr>
-              <a:t>NO — a separate application, already built and running. It feeds the existing costing system by export.</a:t>
+              <a:t>NO — a separate application, and it is already built and running.</a:t>
             </a:r>
             <a:endParaRPr lang="en-US" sz="880" dirty="0"/>
           </a:p>
@@ -3313,7 +3313,7 @@
                 <a:ea typeface="Arial" pitchFamily="34" charset="-122"/>
                 <a:cs typeface="Arial" pitchFamily="34" charset="-120"/>
               </a:rPr>
-              <a:t>It does not replace the cost engineer's judgement or the established costing method. It does the data work and the first pass.</a:t>
+              <a:t>It does not replace the cost engineer's judgement. It does the data work and the first pass; the decisions stay with the engineer.</a:t>
             </a:r>
             <a:endParaRPr lang="en-US" sz="880" dirty="0"/>
           </a:p>

</xml_diff>